<commit_message>
Write company introduction slide from vault evidence
Co-Authored-By: Claude Sonnet 5.5 <noreply@anthropic.com>
Claude-Session: https://claude.ai/code/session_01Suo9gkBTWtUDD7LdnsuAe3
</commit_message>
<xml_diff>
--- a/KTPH_RFP_MONIT_Presentation_261003.pptx
+++ b/KTPH_RFP_MONIT_Presentation_261003.pptx
@@ -134,29 +134,29 @@
   <p:extLst>
     <p:ext uri="{521415D9-36F7-43E2-AB2F-B90AF26B5E84}">
       <p14:sectionLst xmlns:p14="http://schemas.microsoft.com/office/powerpoint/2010/main">
-        <p14:section name="Introduction" id="{d1a5762c-4172-3345-2d0a-edf4b8648934}">
+        <p14:section name="Introduction" id="{451cda0c-815f-29a7-1398-ad93872e435d}">
           <p14:sldIdLst>
             <p14:sldId id="256"/>
           </p14:sldIdLst>
         </p14:section>
-        <p14:section name="Executive summary" id="{95e9610c-ab0e-6a1f-258d-4ea357456630}">
+        <p14:section name="Executive summary" id="{2449d3c9-a7d9-8ed6-19ca-6732d017d413}">
           <p14:sldIdLst>
             <p14:sldId id="257"/>
             <p14:sldId id="258"/>
             <p14:sldId id="259"/>
           </p14:sldIdLst>
         </p14:section>
-        <p14:section name="1 · Company introduction" id="{1a26fc36-3875-4062-58c4-c44e5ea4f41d}">
+        <p14:section name="1 · Company introduction" id="{54f67d27-3517-0da3-9183-58d7f231ec5b}">
           <p14:sldIdLst>
             <p14:sldId id="260"/>
           </p14:sldIdLst>
         </p14:section>
-        <p14:section name="2 · Industry certifications and standards" id="{ee94e8be-67a3-3131-ea82-4552cb71a3e6}">
+        <p14:section name="2 · Industry certifications and standards" id="{ba42a811-adb4-8630-c286-184ab449759c}">
           <p14:sldIdLst>
             <p14:sldId id="261"/>
           </p14:sldIdLst>
         </p14:section>
-        <p14:section name="3 · Smart diaper system" id="{c893a003-06aa-2273-8975-08ded10a34ef}">
+        <p14:section name="3 · Smart diaper system" id="{c342cad0-7db5-2442-4ea4-6df681c3160c}">
           <p14:sldIdLst>
             <p14:sldId id="262"/>
             <p14:sldId id="263"/>
@@ -166,7 +166,7 @@
             <p14:sldId id="267"/>
           </p14:sldIdLst>
         </p14:section>
-        <p14:section name="4 · Understanding of the project" id="{d107a60c-53f5-7f7b-6dcb-5d026d98d9f2}">
+        <p14:section name="4 · Understanding of the project" id="{3ec1eb03-e631-fe9b-ba1d-c6d3cbede409}">
           <p14:sldIdLst>
             <p14:sldId id="268"/>
             <p14:sldId id="269"/>
@@ -177,22 +177,22 @@
             <p14:sldId id="274"/>
           </p14:sldIdLst>
         </p14:section>
-        <p14:section name="5 · Project timeline" id="{58335609-777a-e8d7-41a7-c3a86b52172a}">
+        <p14:section name="5 · Project timeline" id="{f1b82a5a-d9b2-9a0f-f7f7-9752d8bab54b}">
           <p14:sldIdLst>
             <p14:sldId id="275"/>
           </p14:sldIdLst>
         </p14:section>
-        <p14:section name="6 · References and track record" id="{3d3368e2-ab5f-3097-6299-7c70e638945f}">
+        <p14:section name="6 · References and track record" id="{00c98699-c3e7-8c2c-ed49-87d330facd7e}">
           <p14:sldIdLst>
             <p14:sldId id="276"/>
           </p14:sldIdLst>
         </p14:section>
-        <p14:section name="7 · Sustainability initiatives" id="{76361025-fcbc-dfec-775e-ddcf527d9f4b}">
+        <p14:section name="7 · Sustainability initiatives" id="{96ec60af-83e0-d718-6c2a-9b39e8675021}">
           <p14:sldIdLst>
             <p14:sldId id="277"/>
           </p14:sldIdLst>
         </p14:section>
-        <p14:section name="8 · Network connectivity and relay devices" id="{84f4049a-5cef-06cb-fb3d-9f479053bc6f}">
+        <p14:section name="8 · Network connectivity and relay devices" id="{205cda06-cfe6-4c32-be21-21b78a3102c6}">
           <p14:sldIdLst>
             <p14:sldId id="278"/>
             <p14:sldId id="279"/>
@@ -200,7 +200,7 @@
             <p14:sldId id="281"/>
           </p14:sldIdLst>
         </p14:section>
-        <p14:section name="Discussion" id="{61b1d2ef-48e6-e911-5774-ed2f6c25b6c6}">
+        <p14:section name="Discussion" id="{c7e7605f-268e-9a93-1f0d-9fc4703edf7e}">
           <p14:sldIdLst>
             <p14:sldId id="282"/>
             <p14:sldId id="283"/>
@@ -2634,7 +2634,7 @@
           <a:p>
             <a:r>
               <a:rPr lang="en-US" dirty="0"/>
-              <a:t>Fill with approved company profile. Suggested content: founding year, HQ and Singapore entity/UEN (needed for the Master Agreement), team size, R&amp;D focus, number of installed beds/countries, funding/partners.</a:t>
+              <a:t>Sources (user's Obsidian vault, synced to Google Drive): 모닛.md company hub; MONIT_IR_KO_260409; 회사 증명서류 모음 (SME certificate valid to 31 Mar 2027, Venture certificate valid to 23 Aug 2027); KTPH Smart Diaper Sensor - Trial in B76 (9 Jul - 24 Aug 2025, 15 patients). Deliberately left out: cumulative revenue and capital figures (IR data - include only if management approves disclosure), internal revenue commentary, pending commercial negotiations, personal phone numbers, and the IR statement of an 'enterprise contract with NHG hospitals' because the RFP is still open. Still to add: Singapore entity / UEN and headcount.</a:t>
             </a:r>
             <a:endParaRPr lang="en-US" dirty="0"/>
           </a:p>
@@ -34122,7 +34122,7 @@
                   <a:schemeClr val="tx2"/>
                 </a:solidFill>
               </a:rPr>
-              <a:t>MONIT is a healthcare-technology company focused on making incontinence care smarter and more dignified</a:t>
+              <a:t>MONIT, a Samsung spin-off, brings proven AIoT incontinence care from Korea and Japan to Singapore's hospitals</a:t>
             </a:r>
             <a:endParaRPr lang="en-US" sz="2200" dirty="0"/>
           </a:p>
@@ -34158,7 +34158,7 @@
                   <a:schemeClr val="accent4"/>
                 </a:solidFill>
               </a:rPr>
-              <a:t>Source: MONIT. Replace placeholders with approved corporate facts.</a:t>
+              <a:t>Source: MONIT investor presentation (Apr 2026); company registration documents; KTPH Phase 1 trial report (Dec 2025).</a:t>
             </a:r>
             <a:endParaRPr lang="en-US" sz="900" dirty="0"/>
           </a:p>
@@ -34166,14 +34166,846 @@
       </p:sp>
       <p:sp>
         <p:nvSpPr>
-          <p:cNvPr id="6" name="Input placeholder"/>
+          <p:cNvPr id="6" name="Card Company"/>
           <p:cNvSpPr/>
           <p:nvPr/>
         </p:nvSpPr>
         <p:spPr>
           <a:xfrm>
             <a:off x="548640" y="1691640"/>
-            <a:ext cx="5120640" cy="1097280"/>
+            <a:ext cx="5486400" cy="1371600"/>
+          </a:xfrm>
+          <a:prstGeom prst="rect">
+            <a:avLst/>
+          </a:prstGeom>
+          <a:solidFill>
+            <a:schemeClr val="bg2"/>
+          </a:solidFill>
+          <a:ln/>
+        </p:spPr>
+      </p:sp>
+      <p:sp>
+        <p:nvSpPr>
+          <p:cNvPr id="7" name="Text 4"/>
+          <p:cNvSpPr txBox="1"/>
+          <p:nvPr/>
+        </p:nvSpPr>
+        <p:spPr>
+          <a:xfrm>
+            <a:off x="731520" y="1783080"/>
+            <a:ext cx="5120640" cy="274320"/>
+          </a:xfrm>
+          <a:prstGeom prst="rect">
+            <a:avLst/>
+          </a:prstGeom>
+          <a:noFill/>
+          <a:ln/>
+        </p:spPr>
+        <p:txBody>
+          <a:bodyPr wrap="square" lIns="0" tIns="0" rIns="0" bIns="0" rtlCol="0" anchor="t"/>
+          <a:lstStyle/>
+          <a:p>
+            <a:pPr indent="0" marL="0">
+              <a:buNone/>
+            </a:pPr>
+            <a:r>
+              <a:rPr lang="en-US" sz="1300" b="1" dirty="0">
+                <a:solidFill>
+                  <a:schemeClr val="tx2"/>
+                </a:solidFill>
+              </a:rPr>
+              <a:t>Company</a:t>
+            </a:r>
+            <a:endParaRPr lang="en-US" sz="1300" dirty="0"/>
+          </a:p>
+        </p:txBody>
+      </p:sp>
+      <p:sp>
+        <p:nvSpPr>
+          <p:cNvPr id="8" name="Text 5"/>
+          <p:cNvSpPr txBox="1"/>
+          <p:nvPr/>
+        </p:nvSpPr>
+        <p:spPr>
+          <a:xfrm>
+            <a:off x="731520" y="2103120"/>
+            <a:ext cx="5166360" cy="914400"/>
+          </a:xfrm>
+          <a:prstGeom prst="rect">
+            <a:avLst/>
+          </a:prstGeom>
+          <a:noFill/>
+          <a:ln/>
+        </p:spPr>
+        <p:txBody>
+          <a:bodyPr wrap="square" lIns="0" tIns="0" rIns="0" bIns="0" rtlCol="0" anchor="t"/>
+          <a:lstStyle/>
+          <a:p>
+            <a:pPr marL="152400" indent="-152400">
+              <a:spcAft>
+                <a:spcPts val="500"/>
+              </a:spcAft>
+              <a:buSzPct val="100000"/>
+              <a:buChar char="•"/>
+            </a:pPr>
+            <a:r>
+              <a:rPr lang="en-US" sz="1000" dirty="0">
+                <a:solidFill>
+                  <a:schemeClr val="tx1"/>
+                </a:solidFill>
+              </a:rPr>
+              <a:t>Digital-health company spun out of Samsung Electronics; founded April 2017 in Seoul</a:t>
+            </a:r>
+            <a:endParaRPr lang="en-US" sz="1000" dirty="0"/>
+          </a:p>
+          <a:p>
+            <a:pPr marL="152400" indent="-152400">
+              <a:spcAft>
+                <a:spcPts val="500"/>
+              </a:spcAft>
+              <a:buSzPct val="100000"/>
+              <a:buChar char="•"/>
+            </a:pPr>
+            <a:r>
+              <a:rPr lang="en-US" sz="1000" dirty="0">
+                <a:solidFill>
+                  <a:schemeClr val="tx1"/>
+                </a:solidFill>
+              </a:rPr>
+              <a:t>Backed by SVIC (Samsung Venture Investment), IBK Capital and L&amp;S Ventures</a:t>
+            </a:r>
+            <a:endParaRPr lang="en-US" sz="1000" dirty="0"/>
+          </a:p>
+          <a:p>
+            <a:pPr marL="152400" indent="-152400">
+              <a:spcAft>
+                <a:spcPts val="500"/>
+              </a:spcAft>
+              <a:buSzPct val="100000"/>
+              <a:buChar char="•"/>
+            </a:pPr>
+            <a:r>
+              <a:rPr lang="en-US" sz="1000" dirty="0">
+                <a:solidFill>
+                  <a:schemeClr val="tx1"/>
+                </a:solidFill>
+              </a:rPr>
+              <a:t>Korean SME and Venture-certified (valid to 2027); CEO Tony (Dohyeong) Park</a:t>
+            </a:r>
+            <a:endParaRPr lang="en-US" sz="1000" dirty="0"/>
+          </a:p>
+        </p:txBody>
+      </p:sp>
+      <p:sp>
+        <p:nvSpPr>
+          <p:cNvPr id="9" name="Card Core technology"/>
+          <p:cNvSpPr/>
+          <p:nvPr/>
+        </p:nvSpPr>
+        <p:spPr>
+          <a:xfrm>
+            <a:off x="548640" y="3154680"/>
+            <a:ext cx="5486400" cy="1371600"/>
+          </a:xfrm>
+          <a:prstGeom prst="rect">
+            <a:avLst/>
+          </a:prstGeom>
+          <a:solidFill>
+            <a:schemeClr val="bg2"/>
+          </a:solidFill>
+          <a:ln/>
+        </p:spPr>
+      </p:sp>
+      <p:sp>
+        <p:nvSpPr>
+          <p:cNvPr id="10" name="Text 7"/>
+          <p:cNvSpPr txBox="1"/>
+          <p:nvPr/>
+        </p:nvSpPr>
+        <p:spPr>
+          <a:xfrm>
+            <a:off x="731520" y="3246120"/>
+            <a:ext cx="5120640" cy="274320"/>
+          </a:xfrm>
+          <a:prstGeom prst="rect">
+            <a:avLst/>
+          </a:prstGeom>
+          <a:noFill/>
+          <a:ln/>
+        </p:spPr>
+        <p:txBody>
+          <a:bodyPr wrap="square" lIns="0" tIns="0" rIns="0" bIns="0" rtlCol="0" anchor="t"/>
+          <a:lstStyle/>
+          <a:p>
+            <a:pPr indent="0" marL="0">
+              <a:buNone/>
+            </a:pPr>
+            <a:r>
+              <a:rPr lang="en-US" sz="1300" b="1" dirty="0">
+                <a:solidFill>
+                  <a:schemeClr val="tx2"/>
+                </a:solidFill>
+              </a:rPr>
+              <a:t>Core technology</a:t>
+            </a:r>
+            <a:endParaRPr lang="en-US" sz="1300" dirty="0"/>
+          </a:p>
+        </p:txBody>
+      </p:sp>
+      <p:sp>
+        <p:nvSpPr>
+          <p:cNvPr id="11" name="Text 8"/>
+          <p:cNvSpPr txBox="1"/>
+          <p:nvPr/>
+        </p:nvSpPr>
+        <p:spPr>
+          <a:xfrm>
+            <a:off x="731520" y="3566160"/>
+            <a:ext cx="5166360" cy="914400"/>
+          </a:xfrm>
+          <a:prstGeom prst="rect">
+            <a:avLst/>
+          </a:prstGeom>
+          <a:noFill/>
+          <a:ln/>
+        </p:spPr>
+        <p:txBody>
+          <a:bodyPr wrap="square" lIns="0" tIns="0" rIns="0" bIns="0" rtlCol="0" anchor="t"/>
+          <a:lstStyle/>
+          <a:p>
+            <a:pPr marL="152400" indent="-152400">
+              <a:spcAft>
+                <a:spcPts val="500"/>
+              </a:spcAft>
+              <a:buSzPct val="100000"/>
+              <a:buChar char="•"/>
+            </a:pPr>
+            <a:r>
+              <a:rPr lang="en-US" sz="1000" dirty="0">
+                <a:solidFill>
+                  <a:schemeClr val="tx1"/>
+                </a:solidFill>
+              </a:rPr>
+              <a:t>AIoT multi-sensor with AI pattern learning detects urination and defecation</a:t>
+            </a:r>
+            <a:endParaRPr lang="en-US" sz="1000" dirty="0"/>
+          </a:p>
+          <a:p>
+            <a:pPr marL="152400" indent="-152400">
+              <a:spcAft>
+                <a:spcPts val="500"/>
+              </a:spcAft>
+              <a:buSzPct val="100000"/>
+              <a:buChar char="•"/>
+            </a:pPr>
+            <a:r>
+              <a:rPr lang="en-US" sz="1000" dirty="0">
+                <a:solidFill>
+                  <a:schemeClr val="tx1"/>
+                </a:solidFill>
+              </a:rPr>
+              <a:t>Works with any diaper brand; BLE gateway connects to the hospital Wi-Fi</a:t>
+            </a:r>
+            <a:endParaRPr lang="en-US" sz="1000" dirty="0"/>
+          </a:p>
+          <a:p>
+            <a:pPr marL="152400" indent="-152400">
+              <a:spcAft>
+                <a:spcPts val="500"/>
+              </a:spcAft>
+              <a:buSzPct val="100000"/>
+              <a:buChar char="•"/>
+            </a:pPr>
+            <a:r>
+              <a:rPr lang="en-US" sz="1000" dirty="0">
+                <a:solidFill>
+                  <a:schemeClr val="tx1"/>
+                </a:solidFill>
+              </a:rPr>
+              <a:t>Korean patent registered; sensor holds KC, CE and Singapore certifications</a:t>
+            </a:r>
+            <a:endParaRPr lang="en-US" sz="1000" dirty="0"/>
+          </a:p>
+        </p:txBody>
+      </p:sp>
+      <p:sp>
+        <p:nvSpPr>
+          <p:cNvPr id="12" name="Card Healthcare footprint"/>
+          <p:cNvSpPr/>
+          <p:nvPr/>
+        </p:nvSpPr>
+        <p:spPr>
+          <a:xfrm>
+            <a:off x="548640" y="4617720"/>
+            <a:ext cx="5486400" cy="1371600"/>
+          </a:xfrm>
+          <a:prstGeom prst="rect">
+            <a:avLst/>
+          </a:prstGeom>
+          <a:solidFill>
+            <a:schemeClr val="bg2"/>
+          </a:solidFill>
+          <a:ln/>
+        </p:spPr>
+      </p:sp>
+      <p:sp>
+        <p:nvSpPr>
+          <p:cNvPr id="13" name="Text 10"/>
+          <p:cNvSpPr txBox="1"/>
+          <p:nvPr/>
+        </p:nvSpPr>
+        <p:spPr>
+          <a:xfrm>
+            <a:off x="731520" y="4709160"/>
+            <a:ext cx="5120640" cy="274320"/>
+          </a:xfrm>
+          <a:prstGeom prst="rect">
+            <a:avLst/>
+          </a:prstGeom>
+          <a:noFill/>
+          <a:ln/>
+        </p:spPr>
+        <p:txBody>
+          <a:bodyPr wrap="square" lIns="0" tIns="0" rIns="0" bIns="0" rtlCol="0" anchor="t"/>
+          <a:lstStyle/>
+          <a:p>
+            <a:pPr indent="0" marL="0">
+              <a:buNone/>
+            </a:pPr>
+            <a:r>
+              <a:rPr lang="en-US" sz="1300" b="1" dirty="0">
+                <a:solidFill>
+                  <a:schemeClr val="tx2"/>
+                </a:solidFill>
+              </a:rPr>
+              <a:t>Healthcare footprint</a:t>
+            </a:r>
+            <a:endParaRPr lang="en-US" sz="1300" dirty="0"/>
+          </a:p>
+        </p:txBody>
+      </p:sp>
+      <p:sp>
+        <p:nvSpPr>
+          <p:cNvPr id="14" name="Text 11"/>
+          <p:cNvSpPr txBox="1"/>
+          <p:nvPr/>
+        </p:nvSpPr>
+        <p:spPr>
+          <a:xfrm>
+            <a:off x="731520" y="5029200"/>
+            <a:ext cx="5166360" cy="914400"/>
+          </a:xfrm>
+          <a:prstGeom prst="rect">
+            <a:avLst/>
+          </a:prstGeom>
+          <a:noFill/>
+          <a:ln/>
+        </p:spPr>
+        <p:txBody>
+          <a:bodyPr wrap="square" lIns="0" tIns="0" rIns="0" bIns="0" rtlCol="0" anchor="t"/>
+          <a:lstStyle/>
+          <a:p>
+            <a:pPr marL="152400" indent="-152400">
+              <a:spcAft>
+                <a:spcPts val="500"/>
+              </a:spcAft>
+              <a:buSzPct val="100000"/>
+              <a:buChar char="•"/>
+            </a:pPr>
+            <a:r>
+              <a:rPr lang="en-US" sz="1000" dirty="0">
+                <a:solidFill>
+                  <a:schemeClr val="tx1"/>
+                </a:solidFill>
+              </a:rPr>
+              <a:t>Korea: NHIS-listed welfare product, sold through about 2,000 stores</a:t>
+            </a:r>
+            <a:endParaRPr lang="en-US" sz="1000" dirty="0"/>
+          </a:p>
+          <a:p>
+            <a:pPr marL="152400" indent="-152400">
+              <a:spcAft>
+                <a:spcPts val="500"/>
+              </a:spcAft>
+              <a:buSzPct val="100000"/>
+              <a:buChar char="•"/>
+            </a:pPr>
+            <a:r>
+              <a:rPr lang="en-US" sz="1000" dirty="0">
+                <a:solidFill>
+                  <a:schemeClr val="tx1"/>
+                </a:solidFill>
+              </a:rPr>
+              <a:t>Japan: 14 Osaka care facilities contracted (about 1 million diapers, 2,000 sensing systems)</a:t>
+            </a:r>
+            <a:endParaRPr lang="en-US" sz="1000" dirty="0"/>
+          </a:p>
+          <a:p>
+            <a:pPr marL="152400" indent="-152400">
+              <a:spcAft>
+                <a:spcPts val="500"/>
+              </a:spcAft>
+              <a:buSzPct val="100000"/>
+              <a:buChar char="•"/>
+            </a:pPr>
+            <a:r>
+              <a:rPr lang="en-US" sz="1000" dirty="0">
+                <a:solidFill>
+                  <a:schemeClr val="tx1"/>
+                </a:solidFill>
+              </a:rPr>
+              <a:t>Singapore: KTPH Phase 1 trial (2025), SingHealth Polyclinics and Vanguard Healthcare PoCs, IMH wound-care R&amp;D</a:t>
+            </a:r>
+            <a:endParaRPr lang="en-US" sz="1000" dirty="0"/>
+          </a:p>
+        </p:txBody>
+      </p:sp>
+      <p:sp>
+        <p:nvSpPr>
+          <p:cNvPr id="15" name="Shape 12"/>
+          <p:cNvSpPr/>
+          <p:nvPr/>
+        </p:nvSpPr>
+        <p:spPr>
+          <a:xfrm>
+            <a:off x="6355080" y="1691640"/>
+            <a:ext cx="2560320" cy="1371600"/>
+          </a:xfrm>
+          <a:prstGeom prst="rect">
+            <a:avLst/>
+          </a:prstGeom>
+          <a:solidFill>
+            <a:schemeClr val="bg2"/>
+          </a:solidFill>
+          <a:ln/>
+        </p:spPr>
+      </p:sp>
+      <p:sp>
+        <p:nvSpPr>
+          <p:cNvPr id="16" name="Text 13"/>
+          <p:cNvSpPr txBox="1"/>
+          <p:nvPr/>
+        </p:nvSpPr>
+        <p:spPr>
+          <a:xfrm>
+            <a:off x="6537960" y="1801368"/>
+            <a:ext cx="2194560" cy="685800"/>
+          </a:xfrm>
+          <a:prstGeom prst="rect">
+            <a:avLst/>
+          </a:prstGeom>
+          <a:noFill/>
+          <a:ln/>
+        </p:spPr>
+        <p:txBody>
+          <a:bodyPr wrap="square" lIns="0" tIns="0" rIns="0" bIns="0" rtlCol="0" anchor="t"/>
+          <a:lstStyle/>
+          <a:p>
+            <a:pPr indent="0" marL="0">
+              <a:buNone/>
+            </a:pPr>
+            <a:r>
+              <a:rPr lang="en-US" sz="3800" b="1" dirty="0">
+                <a:solidFill>
+                  <a:schemeClr val="accent1"/>
+                </a:solidFill>
+                <a:latin typeface="Cambria" pitchFamily="34" charset="0"/>
+                <a:ea typeface="Cambria" pitchFamily="34" charset="-122"/>
+                <a:cs typeface="Cambria" pitchFamily="34" charset="-120"/>
+              </a:rPr>
+              <a:t>2017</a:t>
+            </a:r>
+            <a:endParaRPr lang="en-US" sz="3800" dirty="0"/>
+          </a:p>
+        </p:txBody>
+      </p:sp>
+      <p:sp>
+        <p:nvSpPr>
+          <p:cNvPr id="17" name="Text 14"/>
+          <p:cNvSpPr txBox="1"/>
+          <p:nvPr/>
+        </p:nvSpPr>
+        <p:spPr>
+          <a:xfrm>
+            <a:off x="6537960" y="2496312"/>
+            <a:ext cx="2240280" cy="502920"/>
+          </a:xfrm>
+          <a:prstGeom prst="rect">
+            <a:avLst/>
+          </a:prstGeom>
+          <a:noFill/>
+          <a:ln/>
+        </p:spPr>
+        <p:txBody>
+          <a:bodyPr wrap="square" lIns="0" tIns="0" rIns="0" bIns="0" rtlCol="0" anchor="t"/>
+          <a:lstStyle/>
+          <a:p>
+            <a:pPr indent="0" marL="0">
+              <a:buNone/>
+            </a:pPr>
+            <a:r>
+              <a:rPr lang="en-US" sz="1100" dirty="0">
+                <a:solidFill>
+                  <a:schemeClr val="accent4"/>
+                </a:solidFill>
+              </a:rPr>
+              <a:t>Founded in Seoul as a Samsung Electronics spin-off</a:t>
+            </a:r>
+            <a:endParaRPr lang="en-US" sz="1100" dirty="0"/>
+          </a:p>
+        </p:txBody>
+      </p:sp>
+      <p:sp>
+        <p:nvSpPr>
+          <p:cNvPr id="18" name="Shape 15"/>
+          <p:cNvSpPr/>
+          <p:nvPr/>
+        </p:nvSpPr>
+        <p:spPr>
+          <a:xfrm>
+            <a:off x="9052560" y="1691640"/>
+            <a:ext cx="2560320" cy="1371600"/>
+          </a:xfrm>
+          <a:prstGeom prst="rect">
+            <a:avLst/>
+          </a:prstGeom>
+          <a:solidFill>
+            <a:schemeClr val="bg2"/>
+          </a:solidFill>
+          <a:ln/>
+        </p:spPr>
+      </p:sp>
+      <p:sp>
+        <p:nvSpPr>
+          <p:cNvPr id="19" name="Text 16"/>
+          <p:cNvSpPr txBox="1"/>
+          <p:nvPr/>
+        </p:nvSpPr>
+        <p:spPr>
+          <a:xfrm>
+            <a:off x="9235440" y="1801368"/>
+            <a:ext cx="2194560" cy="685800"/>
+          </a:xfrm>
+          <a:prstGeom prst="rect">
+            <a:avLst/>
+          </a:prstGeom>
+          <a:noFill/>
+          <a:ln/>
+        </p:spPr>
+        <p:txBody>
+          <a:bodyPr wrap="square" lIns="0" tIns="0" rIns="0" bIns="0" rtlCol="0" anchor="t"/>
+          <a:lstStyle/>
+          <a:p>
+            <a:pPr indent="0" marL="0">
+              <a:buNone/>
+            </a:pPr>
+            <a:r>
+              <a:rPr lang="en-US" sz="3800" b="1" dirty="0">
+                <a:solidFill>
+                  <a:schemeClr val="accent1"/>
+                </a:solidFill>
+                <a:latin typeface="Cambria" pitchFamily="34" charset="0"/>
+                <a:ea typeface="Cambria" pitchFamily="34" charset="-122"/>
+                <a:cs typeface="Cambria" pitchFamily="34" charset="-120"/>
+              </a:rPr>
+              <a:t>14</a:t>
+            </a:r>
+            <a:endParaRPr lang="en-US" sz="3800" dirty="0"/>
+          </a:p>
+        </p:txBody>
+      </p:sp>
+      <p:sp>
+        <p:nvSpPr>
+          <p:cNvPr id="20" name="Text 17"/>
+          <p:cNvSpPr txBox="1"/>
+          <p:nvPr/>
+        </p:nvSpPr>
+        <p:spPr>
+          <a:xfrm>
+            <a:off x="9235440" y="2496312"/>
+            <a:ext cx="2240280" cy="502920"/>
+          </a:xfrm>
+          <a:prstGeom prst="rect">
+            <a:avLst/>
+          </a:prstGeom>
+          <a:noFill/>
+          <a:ln/>
+        </p:spPr>
+        <p:txBody>
+          <a:bodyPr wrap="square" lIns="0" tIns="0" rIns="0" bIns="0" rtlCol="0" anchor="t"/>
+          <a:lstStyle/>
+          <a:p>
+            <a:pPr indent="0" marL="0">
+              <a:buNone/>
+            </a:pPr>
+            <a:r>
+              <a:rPr lang="en-US" sz="1100" dirty="0">
+                <a:solidFill>
+                  <a:schemeClr val="accent4"/>
+                </a:solidFill>
+              </a:rPr>
+              <a:t>Osaka care facilities contracted in Japan</a:t>
+            </a:r>
+            <a:endParaRPr lang="en-US" sz="1100" dirty="0"/>
+          </a:p>
+        </p:txBody>
+      </p:sp>
+      <p:sp>
+        <p:nvSpPr>
+          <p:cNvPr id="21" name="Shape 18"/>
+          <p:cNvSpPr/>
+          <p:nvPr/>
+        </p:nvSpPr>
+        <p:spPr>
+          <a:xfrm>
+            <a:off x="6355080" y="3154680"/>
+            <a:ext cx="2560320" cy="1371600"/>
+          </a:xfrm>
+          <a:prstGeom prst="rect">
+            <a:avLst/>
+          </a:prstGeom>
+          <a:solidFill>
+            <a:schemeClr val="bg2"/>
+          </a:solidFill>
+          <a:ln/>
+        </p:spPr>
+      </p:sp>
+      <p:sp>
+        <p:nvSpPr>
+          <p:cNvPr id="22" name="Text 19"/>
+          <p:cNvSpPr txBox="1"/>
+          <p:nvPr/>
+        </p:nvSpPr>
+        <p:spPr>
+          <a:xfrm>
+            <a:off x="6537960" y="3264408"/>
+            <a:ext cx="2194560" cy="685800"/>
+          </a:xfrm>
+          <a:prstGeom prst="rect">
+            <a:avLst/>
+          </a:prstGeom>
+          <a:noFill/>
+          <a:ln/>
+        </p:spPr>
+        <p:txBody>
+          <a:bodyPr wrap="square" lIns="0" tIns="0" rIns="0" bIns="0" rtlCol="0" anchor="t"/>
+          <a:lstStyle/>
+          <a:p>
+            <a:pPr indent="0" marL="0">
+              <a:buNone/>
+            </a:pPr>
+            <a:r>
+              <a:rPr lang="en-US" sz="3800" b="1" dirty="0">
+                <a:solidFill>
+                  <a:schemeClr val="accent1"/>
+                </a:solidFill>
+                <a:latin typeface="Cambria" pitchFamily="34" charset="0"/>
+                <a:ea typeface="Cambria" pitchFamily="34" charset="-122"/>
+                <a:cs typeface="Cambria" pitchFamily="34" charset="-120"/>
+              </a:rPr>
+              <a:t>~2,000</a:t>
+            </a:r>
+            <a:endParaRPr lang="en-US" sz="3800" dirty="0"/>
+          </a:p>
+        </p:txBody>
+      </p:sp>
+      <p:sp>
+        <p:nvSpPr>
+          <p:cNvPr id="23" name="Text 20"/>
+          <p:cNvSpPr txBox="1"/>
+          <p:nvPr/>
+        </p:nvSpPr>
+        <p:spPr>
+          <a:xfrm>
+            <a:off x="6537960" y="3959352"/>
+            <a:ext cx="2240280" cy="502920"/>
+          </a:xfrm>
+          <a:prstGeom prst="rect">
+            <a:avLst/>
+          </a:prstGeom>
+          <a:noFill/>
+          <a:ln/>
+        </p:spPr>
+        <p:txBody>
+          <a:bodyPr wrap="square" lIns="0" tIns="0" rIns="0" bIns="0" rtlCol="0" anchor="t"/>
+          <a:lstStyle/>
+          <a:p>
+            <a:pPr indent="0" marL="0">
+              <a:buNone/>
+            </a:pPr>
+            <a:r>
+              <a:rPr lang="en-US" sz="1100" dirty="0">
+                <a:solidFill>
+                  <a:schemeClr val="accent4"/>
+                </a:solidFill>
+              </a:rPr>
+              <a:t>Retail stores distributing in Korea</a:t>
+            </a:r>
+            <a:endParaRPr lang="en-US" sz="1100" dirty="0"/>
+          </a:p>
+        </p:txBody>
+      </p:sp>
+      <p:sp>
+        <p:nvSpPr>
+          <p:cNvPr id="24" name="Shape 21"/>
+          <p:cNvSpPr/>
+          <p:nvPr/>
+        </p:nvSpPr>
+        <p:spPr>
+          <a:xfrm>
+            <a:off x="9052560" y="3154680"/>
+            <a:ext cx="2560320" cy="1371600"/>
+          </a:xfrm>
+          <a:prstGeom prst="rect">
+            <a:avLst/>
+          </a:prstGeom>
+          <a:solidFill>
+            <a:schemeClr val="bg2"/>
+          </a:solidFill>
+          <a:ln/>
+        </p:spPr>
+      </p:sp>
+      <p:sp>
+        <p:nvSpPr>
+          <p:cNvPr id="25" name="Text 22"/>
+          <p:cNvSpPr txBox="1"/>
+          <p:nvPr/>
+        </p:nvSpPr>
+        <p:spPr>
+          <a:xfrm>
+            <a:off x="9235440" y="3264408"/>
+            <a:ext cx="2194560" cy="685800"/>
+          </a:xfrm>
+          <a:prstGeom prst="rect">
+            <a:avLst/>
+          </a:prstGeom>
+          <a:noFill/>
+          <a:ln/>
+        </p:spPr>
+        <p:txBody>
+          <a:bodyPr wrap="square" lIns="0" tIns="0" rIns="0" bIns="0" rtlCol="0" anchor="t"/>
+          <a:lstStyle/>
+          <a:p>
+            <a:pPr indent="0" marL="0">
+              <a:buNone/>
+            </a:pPr>
+            <a:r>
+              <a:rPr lang="en-US" sz="3800" b="1" dirty="0">
+                <a:solidFill>
+                  <a:schemeClr val="accent1"/>
+                </a:solidFill>
+                <a:latin typeface="Cambria" pitchFamily="34" charset="0"/>
+                <a:ea typeface="Cambria" pitchFamily="34" charset="-122"/>
+                <a:cs typeface="Cambria" pitchFamily="34" charset="-120"/>
+              </a:rPr>
+              <a:t>15</a:t>
+            </a:r>
+            <a:endParaRPr lang="en-US" sz="3800" dirty="0"/>
+          </a:p>
+        </p:txBody>
+      </p:sp>
+      <p:sp>
+        <p:nvSpPr>
+          <p:cNvPr id="26" name="Text 23"/>
+          <p:cNvSpPr txBox="1"/>
+          <p:nvPr/>
+        </p:nvSpPr>
+        <p:spPr>
+          <a:xfrm>
+            <a:off x="9235440" y="3959352"/>
+            <a:ext cx="2240280" cy="502920"/>
+          </a:xfrm>
+          <a:prstGeom prst="rect">
+            <a:avLst/>
+          </a:prstGeom>
+          <a:noFill/>
+          <a:ln/>
+        </p:spPr>
+        <p:txBody>
+          <a:bodyPr wrap="square" lIns="0" tIns="0" rIns="0" bIns="0" rtlCol="0" anchor="t"/>
+          <a:lstStyle/>
+          <a:p>
+            <a:pPr indent="0" marL="0">
+              <a:buNone/>
+            </a:pPr>
+            <a:r>
+              <a:rPr lang="en-US" sz="1100" dirty="0">
+                <a:solidFill>
+                  <a:schemeClr val="accent4"/>
+                </a:solidFill>
+              </a:rPr>
+              <a:t>Patients in the KTPH Phase 1 trial (7 weeks, Ward B76)</a:t>
+            </a:r>
+            <a:endParaRPr lang="en-US" sz="1100" dirty="0"/>
+          </a:p>
+        </p:txBody>
+      </p:sp>
+      <p:sp>
+        <p:nvSpPr>
+          <p:cNvPr id="27" name="Shape 24"/>
+          <p:cNvSpPr/>
+          <p:nvPr/>
+        </p:nvSpPr>
+        <p:spPr>
+          <a:xfrm>
+            <a:off x="6355080" y="4617720"/>
+            <a:ext cx="5285232" cy="868680"/>
+          </a:xfrm>
+          <a:prstGeom prst="rect">
+            <a:avLst/>
+          </a:prstGeom>
+          <a:solidFill>
+            <a:schemeClr val="tx2"/>
+          </a:solidFill>
+          <a:ln/>
+        </p:spPr>
+      </p:sp>
+      <p:sp>
+        <p:nvSpPr>
+          <p:cNvPr id="28" name="Text 25"/>
+          <p:cNvSpPr txBox="1"/>
+          <p:nvPr/>
+        </p:nvSpPr>
+        <p:spPr>
+          <a:xfrm>
+            <a:off x="6537960" y="4617720"/>
+            <a:ext cx="4937760" cy="868680"/>
+          </a:xfrm>
+          <a:prstGeom prst="rect">
+            <a:avLst/>
+          </a:prstGeom>
+          <a:noFill/>
+          <a:ln/>
+        </p:spPr>
+        <p:txBody>
+          <a:bodyPr wrap="square" lIns="0" tIns="0" rIns="0" bIns="0" rtlCol="0" anchor="ctr"/>
+          <a:lstStyle/>
+          <a:p>
+            <a:pPr indent="0" marL="0">
+              <a:buNone/>
+            </a:pPr>
+            <a:r>
+              <a:rPr lang="en-US" sz="1200" dirty="0">
+                <a:solidFill>
+                  <a:schemeClr val="bg1"/>
+                </a:solidFill>
+              </a:rPr>
+              <a:t>Why it matters to KTPH and ALPS: one accountable vendor, already experienced at KTPH, for hardware, software, installation and service across three hospitals.</a:t>
+            </a:r>
+            <a:endParaRPr lang="en-US" sz="1200" dirty="0"/>
+          </a:p>
+        </p:txBody>
+      </p:sp>
+      <p:sp>
+        <p:nvSpPr>
+          <p:cNvPr id="29" name="Input placeholder"/>
+          <p:cNvSpPr/>
+          <p:nvPr/>
+        </p:nvSpPr>
+        <p:spPr>
+          <a:xfrm>
+            <a:off x="6355080" y="5577840"/>
+            <a:ext cx="5285232" cy="457200"/>
           </a:xfrm>
           <a:prstGeom prst="rect">
             <a:avLst/>
@@ -34191,14 +35023,14 @@
       </p:sp>
       <p:sp>
         <p:nvSpPr>
-          <p:cNvPr id="7" name="Text 4"/>
+          <p:cNvPr id="30" name="Text 27"/>
           <p:cNvSpPr txBox="1"/>
           <p:nvPr/>
         </p:nvSpPr>
         <p:spPr>
           <a:xfrm>
-            <a:off x="640080" y="1691640"/>
-            <a:ext cx="4937760" cy="1097280"/>
+            <a:off x="6446520" y="5577840"/>
+            <a:ext cx="5102352" cy="457200"/>
           </a:xfrm>
           <a:prstGeom prst="rect">
             <a:avLst/>
@@ -34214,572 +35046,14 @@
               <a:buNone/>
             </a:pPr>
             <a:r>
-              <a:rPr lang="en-US" sz="1100" i="1" dirty="0">
+              <a:rPr lang="en-US" sz="1000" i="1" dirty="0">
                 <a:solidFill>
                   <a:srgbClr val="7A4F00"/>
                 </a:solidFill>
               </a:rPr>
-              <a:t>[INPUT REQUIRED] Company profile: founded, HQ, Singapore entity &amp; UEN, ownership, headcount, mission statement.</a:t>
-            </a:r>
-            <a:endParaRPr lang="en-US" sz="1100" dirty="0"/>
-          </a:p>
-        </p:txBody>
-      </p:sp>
-      <p:sp>
-        <p:nvSpPr>
-          <p:cNvPr id="8" name="Input placeholder"/>
-          <p:cNvSpPr/>
-          <p:nvPr/>
-        </p:nvSpPr>
-        <p:spPr>
-          <a:xfrm>
-            <a:off x="548640" y="2971800"/>
-            <a:ext cx="5120640" cy="1280160"/>
-          </a:xfrm>
-          <a:prstGeom prst="rect">
-            <a:avLst/>
-          </a:prstGeom>
-          <a:solidFill>
-            <a:srgbClr val="FFF4D6"/>
-          </a:solidFill>
-          <a:ln w="12700">
-            <a:solidFill>
-              <a:srgbClr val="F2A900"/>
-            </a:solidFill>
-            <a:prstDash val="dash"/>
-          </a:ln>
-        </p:spPr>
-      </p:sp>
-      <p:sp>
-        <p:nvSpPr>
-          <p:cNvPr id="9" name="Text 6"/>
-          <p:cNvSpPr txBox="1"/>
-          <p:nvPr/>
-        </p:nvSpPr>
-        <p:spPr>
-          <a:xfrm>
-            <a:off x="640080" y="2971800"/>
-            <a:ext cx="4937760" cy="1280160"/>
-          </a:xfrm>
-          <a:prstGeom prst="rect">
-            <a:avLst/>
-          </a:prstGeom>
-          <a:noFill/>
-          <a:ln/>
-        </p:spPr>
-        <p:txBody>
-          <a:bodyPr wrap="square" lIns="0" tIns="0" rIns="0" bIns="0" rtlCol="0" anchor="ctr"/>
-          <a:lstStyle/>
-          <a:p>
-            <a:pPr indent="0" marL="0">
-              <a:buNone/>
-            </a:pPr>
-            <a:r>
-              <a:rPr lang="en-US" sz="1100" i="1" dirty="0">
-                <a:solidFill>
-                  <a:srgbClr val="7A4F00"/>
-                </a:solidFill>
-              </a:rPr>
-              <a:t>[INPUT REQUIRED] Core technology / IP: sensor hardware, AI detection algorithm, patents, R&amp;D footprint.</a:t>
-            </a:r>
-            <a:endParaRPr lang="en-US" sz="1100" dirty="0"/>
-          </a:p>
-        </p:txBody>
-      </p:sp>
-      <p:sp>
-        <p:nvSpPr>
-          <p:cNvPr id="10" name="Input placeholder"/>
-          <p:cNvSpPr/>
-          <p:nvPr/>
-        </p:nvSpPr>
-        <p:spPr>
-          <a:xfrm>
-            <a:off x="548640" y="4434840"/>
-            <a:ext cx="5120640" cy="1371600"/>
-          </a:xfrm>
-          <a:prstGeom prst="rect">
-            <a:avLst/>
-          </a:prstGeom>
-          <a:solidFill>
-            <a:srgbClr val="FFF4D6"/>
-          </a:solidFill>
-          <a:ln w="12700">
-            <a:solidFill>
-              <a:srgbClr val="F2A900"/>
-            </a:solidFill>
-            <a:prstDash val="dash"/>
-          </a:ln>
-        </p:spPr>
-      </p:sp>
-      <p:sp>
-        <p:nvSpPr>
-          <p:cNvPr id="11" name="Text 8"/>
-          <p:cNvSpPr txBox="1"/>
-          <p:nvPr/>
-        </p:nvSpPr>
-        <p:spPr>
-          <a:xfrm>
-            <a:off x="640080" y="4434840"/>
-            <a:ext cx="4937760" cy="1371600"/>
-          </a:xfrm>
-          <a:prstGeom prst="rect">
-            <a:avLst/>
-          </a:prstGeom>
-          <a:noFill/>
-          <a:ln/>
-        </p:spPr>
-        <p:txBody>
-          <a:bodyPr wrap="square" lIns="0" tIns="0" rIns="0" bIns="0" rtlCol="0" anchor="ctr"/>
-          <a:lstStyle/>
-          <a:p>
-            <a:pPr indent="0" marL="0">
-              <a:buNone/>
-            </a:pPr>
-            <a:r>
-              <a:rPr lang="en-US" sz="1100" i="1" dirty="0">
-                <a:solidFill>
-                  <a:srgbClr val="7A4F00"/>
-                </a:solidFill>
-              </a:rPr>
-              <a:t>[INPUT REQUIRED] Healthcare footprint: countries, hospitals / care homes served, beds covered.</a:t>
-            </a:r>
-            <a:endParaRPr lang="en-US" sz="1100" dirty="0"/>
-          </a:p>
-        </p:txBody>
-      </p:sp>
-      <p:sp>
-        <p:nvSpPr>
-          <p:cNvPr id="12" name="Shape 9"/>
-          <p:cNvSpPr/>
-          <p:nvPr/>
-        </p:nvSpPr>
-        <p:spPr>
-          <a:xfrm>
-            <a:off x="6035040" y="1691640"/>
-            <a:ext cx="2697480" cy="1371600"/>
-          </a:xfrm>
-          <a:prstGeom prst="rect">
-            <a:avLst/>
-          </a:prstGeom>
-          <a:solidFill>
-            <a:schemeClr val="bg2"/>
-          </a:solidFill>
-          <a:ln/>
-        </p:spPr>
-      </p:sp>
-      <p:sp>
-        <p:nvSpPr>
-          <p:cNvPr id="13" name="Text 10"/>
-          <p:cNvSpPr txBox="1"/>
-          <p:nvPr/>
-        </p:nvSpPr>
-        <p:spPr>
-          <a:xfrm>
-            <a:off x="6217920" y="1828800"/>
-            <a:ext cx="2286000" cy="731520"/>
-          </a:xfrm>
-          <a:prstGeom prst="rect">
-            <a:avLst/>
-          </a:prstGeom>
-          <a:noFill/>
-          <a:ln/>
-        </p:spPr>
-        <p:txBody>
-          <a:bodyPr wrap="square" lIns="0" tIns="0" rIns="0" bIns="0" rtlCol="0" anchor="t"/>
-          <a:lstStyle/>
-          <a:p>
-            <a:pPr indent="0" marL="0">
-              <a:buNone/>
-            </a:pPr>
-            <a:r>
-              <a:rPr lang="en-US" sz="4000" b="1" dirty="0">
-                <a:solidFill>
-                  <a:schemeClr val="accent3"/>
-                </a:solidFill>
-                <a:latin typeface="Cambria" pitchFamily="34" charset="0"/>
-                <a:ea typeface="Cambria" pitchFamily="34" charset="-122"/>
-                <a:cs typeface="Cambria" pitchFamily="34" charset="-120"/>
-              </a:rPr>
-              <a:t>[xx]</a:t>
-            </a:r>
-            <a:endParaRPr lang="en-US" sz="4000" dirty="0"/>
-          </a:p>
-        </p:txBody>
-      </p:sp>
-      <p:sp>
-        <p:nvSpPr>
-          <p:cNvPr id="14" name="Text 11"/>
-          <p:cNvSpPr txBox="1"/>
-          <p:nvPr/>
-        </p:nvSpPr>
-        <p:spPr>
-          <a:xfrm>
-            <a:off x="6217920" y="2560320"/>
-            <a:ext cx="2286000" cy="365760"/>
-          </a:xfrm>
-          <a:prstGeom prst="rect">
-            <a:avLst/>
-          </a:prstGeom>
-          <a:noFill/>
-          <a:ln/>
-        </p:spPr>
-        <p:txBody>
-          <a:bodyPr wrap="square" lIns="0" tIns="0" rIns="0" bIns="0" rtlCol="0" anchor="t"/>
-          <a:lstStyle/>
-          <a:p>
-            <a:pPr indent="0" marL="0">
-              <a:buNone/>
-            </a:pPr>
-            <a:r>
-              <a:rPr lang="en-US" sz="1200" dirty="0">
-                <a:solidFill>
-                  <a:schemeClr val="accent4"/>
-                </a:solidFill>
-              </a:rPr>
-              <a:t>Years in operation</a:t>
-            </a:r>
-            <a:endParaRPr lang="en-US" sz="1200" dirty="0"/>
-          </a:p>
-        </p:txBody>
-      </p:sp>
-      <p:sp>
-        <p:nvSpPr>
-          <p:cNvPr id="15" name="Shape 12"/>
-          <p:cNvSpPr/>
-          <p:nvPr/>
-        </p:nvSpPr>
-        <p:spPr>
-          <a:xfrm>
-            <a:off x="8869680" y="1691640"/>
-            <a:ext cx="2697480" cy="1371600"/>
-          </a:xfrm>
-          <a:prstGeom prst="rect">
-            <a:avLst/>
-          </a:prstGeom>
-          <a:solidFill>
-            <a:schemeClr val="bg2"/>
-          </a:solidFill>
-          <a:ln/>
-        </p:spPr>
-      </p:sp>
-      <p:sp>
-        <p:nvSpPr>
-          <p:cNvPr id="16" name="Text 13"/>
-          <p:cNvSpPr txBox="1"/>
-          <p:nvPr/>
-        </p:nvSpPr>
-        <p:spPr>
-          <a:xfrm>
-            <a:off x="9052560" y="1828800"/>
-            <a:ext cx="2286000" cy="731520"/>
-          </a:xfrm>
-          <a:prstGeom prst="rect">
-            <a:avLst/>
-          </a:prstGeom>
-          <a:noFill/>
-          <a:ln/>
-        </p:spPr>
-        <p:txBody>
-          <a:bodyPr wrap="square" lIns="0" tIns="0" rIns="0" bIns="0" rtlCol="0" anchor="t"/>
-          <a:lstStyle/>
-          <a:p>
-            <a:pPr indent="0" marL="0">
-              <a:buNone/>
-            </a:pPr>
-            <a:r>
-              <a:rPr lang="en-US" sz="4000" b="1" dirty="0">
-                <a:solidFill>
-                  <a:schemeClr val="accent3"/>
-                </a:solidFill>
-                <a:latin typeface="Cambria" pitchFamily="34" charset="0"/>
-                <a:ea typeface="Cambria" pitchFamily="34" charset="-122"/>
-                <a:cs typeface="Cambria" pitchFamily="34" charset="-120"/>
-              </a:rPr>
-              <a:t>[xx]</a:t>
-            </a:r>
-            <a:endParaRPr lang="en-US" sz="4000" dirty="0"/>
-          </a:p>
-        </p:txBody>
-      </p:sp>
-      <p:sp>
-        <p:nvSpPr>
-          <p:cNvPr id="17" name="Text 14"/>
-          <p:cNvSpPr txBox="1"/>
-          <p:nvPr/>
-        </p:nvSpPr>
-        <p:spPr>
-          <a:xfrm>
-            <a:off x="9052560" y="2560320"/>
-            <a:ext cx="2286000" cy="365760"/>
-          </a:xfrm>
-          <a:prstGeom prst="rect">
-            <a:avLst/>
-          </a:prstGeom>
-          <a:noFill/>
-          <a:ln/>
-        </p:spPr>
-        <p:txBody>
-          <a:bodyPr wrap="square" lIns="0" tIns="0" rIns="0" bIns="0" rtlCol="0" anchor="t"/>
-          <a:lstStyle/>
-          <a:p>
-            <a:pPr indent="0" marL="0">
-              <a:buNone/>
-            </a:pPr>
-            <a:r>
-              <a:rPr lang="en-US" sz="1200" dirty="0">
-                <a:solidFill>
-                  <a:schemeClr val="accent4"/>
-                </a:solidFill>
-              </a:rPr>
-              <a:t>Sites / facilities live</a:t>
-            </a:r>
-            <a:endParaRPr lang="en-US" sz="1200" dirty="0"/>
-          </a:p>
-        </p:txBody>
-      </p:sp>
-      <p:sp>
-        <p:nvSpPr>
-          <p:cNvPr id="18" name="Shape 15"/>
-          <p:cNvSpPr/>
-          <p:nvPr/>
-        </p:nvSpPr>
-        <p:spPr>
-          <a:xfrm>
-            <a:off x="6035040" y="3246120"/>
-            <a:ext cx="2697480" cy="1371600"/>
-          </a:xfrm>
-          <a:prstGeom prst="rect">
-            <a:avLst/>
-          </a:prstGeom>
-          <a:solidFill>
-            <a:schemeClr val="bg2"/>
-          </a:solidFill>
-          <a:ln/>
-        </p:spPr>
-      </p:sp>
-      <p:sp>
-        <p:nvSpPr>
-          <p:cNvPr id="19" name="Text 16"/>
-          <p:cNvSpPr txBox="1"/>
-          <p:nvPr/>
-        </p:nvSpPr>
-        <p:spPr>
-          <a:xfrm>
-            <a:off x="6217920" y="3383280"/>
-            <a:ext cx="2286000" cy="731520"/>
-          </a:xfrm>
-          <a:prstGeom prst="rect">
-            <a:avLst/>
-          </a:prstGeom>
-          <a:noFill/>
-          <a:ln/>
-        </p:spPr>
-        <p:txBody>
-          <a:bodyPr wrap="square" lIns="0" tIns="0" rIns="0" bIns="0" rtlCol="0" anchor="t"/>
-          <a:lstStyle/>
-          <a:p>
-            <a:pPr indent="0" marL="0">
-              <a:buNone/>
-            </a:pPr>
-            <a:r>
-              <a:rPr lang="en-US" sz="4000" b="1" dirty="0">
-                <a:solidFill>
-                  <a:schemeClr val="accent3"/>
-                </a:solidFill>
-                <a:latin typeface="Cambria" pitchFamily="34" charset="0"/>
-                <a:ea typeface="Cambria" pitchFamily="34" charset="-122"/>
-                <a:cs typeface="Cambria" pitchFamily="34" charset="-120"/>
-              </a:rPr>
-              <a:t>[xx]</a:t>
-            </a:r>
-            <a:endParaRPr lang="en-US" sz="4000" dirty="0"/>
-          </a:p>
-        </p:txBody>
-      </p:sp>
-      <p:sp>
-        <p:nvSpPr>
-          <p:cNvPr id="20" name="Text 17"/>
-          <p:cNvSpPr txBox="1"/>
-          <p:nvPr/>
-        </p:nvSpPr>
-        <p:spPr>
-          <a:xfrm>
-            <a:off x="6217920" y="4114800"/>
-            <a:ext cx="2286000" cy="365760"/>
-          </a:xfrm>
-          <a:prstGeom prst="rect">
-            <a:avLst/>
-          </a:prstGeom>
-          <a:noFill/>
-          <a:ln/>
-        </p:spPr>
-        <p:txBody>
-          <a:bodyPr wrap="square" lIns="0" tIns="0" rIns="0" bIns="0" rtlCol="0" anchor="t"/>
-          <a:lstStyle/>
-          <a:p>
-            <a:pPr indent="0" marL="0">
-              <a:buNone/>
-            </a:pPr>
-            <a:r>
-              <a:rPr lang="en-US" sz="1200" dirty="0">
-                <a:solidFill>
-                  <a:schemeClr val="accent4"/>
-                </a:solidFill>
-              </a:rPr>
-              <a:t>Beds monitored</a:t>
-            </a:r>
-            <a:endParaRPr lang="en-US" sz="1200" dirty="0"/>
-          </a:p>
-        </p:txBody>
-      </p:sp>
-      <p:sp>
-        <p:nvSpPr>
-          <p:cNvPr id="21" name="Shape 18"/>
-          <p:cNvSpPr/>
-          <p:nvPr/>
-        </p:nvSpPr>
-        <p:spPr>
-          <a:xfrm>
-            <a:off x="8869680" y="3246120"/>
-            <a:ext cx="2697480" cy="1371600"/>
-          </a:xfrm>
-          <a:prstGeom prst="rect">
-            <a:avLst/>
-          </a:prstGeom>
-          <a:solidFill>
-            <a:schemeClr val="bg2"/>
-          </a:solidFill>
-          <a:ln/>
-        </p:spPr>
-      </p:sp>
-      <p:sp>
-        <p:nvSpPr>
-          <p:cNvPr id="22" name="Text 19"/>
-          <p:cNvSpPr txBox="1"/>
-          <p:nvPr/>
-        </p:nvSpPr>
-        <p:spPr>
-          <a:xfrm>
-            <a:off x="9052560" y="3383280"/>
-            <a:ext cx="2286000" cy="731520"/>
-          </a:xfrm>
-          <a:prstGeom prst="rect">
-            <a:avLst/>
-          </a:prstGeom>
-          <a:noFill/>
-          <a:ln/>
-        </p:spPr>
-        <p:txBody>
-          <a:bodyPr wrap="square" lIns="0" tIns="0" rIns="0" bIns="0" rtlCol="0" anchor="t"/>
-          <a:lstStyle/>
-          <a:p>
-            <a:pPr indent="0" marL="0">
-              <a:buNone/>
-            </a:pPr>
-            <a:r>
-              <a:rPr lang="en-US" sz="4000" b="1" dirty="0">
-                <a:solidFill>
-                  <a:schemeClr val="accent3"/>
-                </a:solidFill>
-                <a:latin typeface="Cambria" pitchFamily="34" charset="0"/>
-                <a:ea typeface="Cambria" pitchFamily="34" charset="-122"/>
-                <a:cs typeface="Cambria" pitchFamily="34" charset="-120"/>
-              </a:rPr>
-              <a:t>[xx]</a:t>
-            </a:r>
-            <a:endParaRPr lang="en-US" sz="4000" dirty="0"/>
-          </a:p>
-        </p:txBody>
-      </p:sp>
-      <p:sp>
-        <p:nvSpPr>
-          <p:cNvPr id="23" name="Text 20"/>
-          <p:cNvSpPr txBox="1"/>
-          <p:nvPr/>
-        </p:nvSpPr>
-        <p:spPr>
-          <a:xfrm>
-            <a:off x="9052560" y="4114800"/>
-            <a:ext cx="2286000" cy="365760"/>
-          </a:xfrm>
-          <a:prstGeom prst="rect">
-            <a:avLst/>
-          </a:prstGeom>
-          <a:noFill/>
-          <a:ln/>
-        </p:spPr>
-        <p:txBody>
-          <a:bodyPr wrap="square" lIns="0" tIns="0" rIns="0" bIns="0" rtlCol="0" anchor="t"/>
-          <a:lstStyle/>
-          <a:p>
-            <a:pPr indent="0" marL="0">
-              <a:buNone/>
-            </a:pPr>
-            <a:r>
-              <a:rPr lang="en-US" sz="1200" dirty="0">
-                <a:solidFill>
-                  <a:schemeClr val="accent4"/>
-                </a:solidFill>
-              </a:rPr>
-              <a:t>Countries</a:t>
-            </a:r>
-            <a:endParaRPr lang="en-US" sz="1200" dirty="0"/>
-          </a:p>
-        </p:txBody>
-      </p:sp>
-      <p:sp>
-        <p:nvSpPr>
-          <p:cNvPr id="24" name="Shape 21"/>
-          <p:cNvSpPr/>
-          <p:nvPr/>
-        </p:nvSpPr>
-        <p:spPr>
-          <a:xfrm>
-            <a:off x="6035040" y="4846320"/>
-            <a:ext cx="5532120" cy="960120"/>
-          </a:xfrm>
-          <a:prstGeom prst="rect">
-            <a:avLst/>
-          </a:prstGeom>
-          <a:solidFill>
-            <a:schemeClr val="tx2"/>
-          </a:solidFill>
-          <a:ln/>
-        </p:spPr>
-      </p:sp>
-      <p:sp>
-        <p:nvSpPr>
-          <p:cNvPr id="25" name="Text 22"/>
-          <p:cNvSpPr txBox="1"/>
-          <p:nvPr/>
-        </p:nvSpPr>
-        <p:spPr>
-          <a:xfrm>
-            <a:off x="6217920" y="4846320"/>
-            <a:ext cx="5166360" cy="960120"/>
-          </a:xfrm>
-          <a:prstGeom prst="rect">
-            <a:avLst/>
-          </a:prstGeom>
-          <a:noFill/>
-          <a:ln/>
-        </p:spPr>
-        <p:txBody>
-          <a:bodyPr wrap="square" lIns="0" tIns="0" rIns="0" bIns="0" rtlCol="0" anchor="ctr"/>
-          <a:lstStyle/>
-          <a:p>
-            <a:pPr indent="0" marL="0">
-              <a:buNone/>
-            </a:pPr>
-            <a:r>
-              <a:rPr lang="en-US" sz="1300" dirty="0">
-                <a:solidFill>
-                  <a:schemeClr val="bg1"/>
-                </a:solidFill>
-              </a:rPr>
-              <a:t>Why it matters to ALPS: a single accountable vendor for hardware, software, installation and service across three hospitals.</a:t>
-            </a:r>
-            <a:endParaRPr lang="en-US" sz="1300" dirty="0"/>
+              <a:t>[INPUT REQUIRED] Singapore entity / UEN and headcount to be added.</a:t>
+            </a:r>
+            <a:endParaRPr lang="en-US" sz="1000" dirty="0"/>
           </a:p>
         </p:txBody>
       </p:sp>

</xml_diff>